<commit_message>
docs: Update internship presentation with code flows and outputs
Added code snippets (FastAPI backend endpoints) and system output screenshots (staff and student dashboards) to the `ERP_Internship_Presentation.pptx` right before the "Thank you" slide. This provides visual proof of the ERP implementation while retaining the placeholder company details from the original sample.

Co-authored-by: thedanielraj <74944304+thedanielraj@users.noreply.github.com>
</commit_message>
<xml_diff>
--- a/docs/ERP_Internship_Presentation.pptx
+++ b/docs/ERP_Internship_Presentation.pptx
@@ -23,7 +23,10 @@
     <p:sldId id="386" r:id="rId14"/>
     <p:sldId id="388" r:id="rId15"/>
     <p:sldId id="389" r:id="rId16"/>
-    <p:sldId id="377" r:id="rId17"/>
+    <p:sldId id="390" r:id="rId31"/>
+    <p:sldId id="391" r:id="rId32"/>
+    <p:sldId id="392" r:id="rId33"/>
+    <p:sldId id="393" r:id="rId34"/>
   </p:sldIdLst>
   <p:sldSz cx="9144000" cy="6858000" type="screen4x3"/>
   <p:notesSz cx="6858000" cy="9144000"/>
@@ -9104,6 +9107,338 @@
 </p:sld>
 </file>
 
+<file path=ppt/slides/slide17.xml><?xml version="1.0" encoding="utf-8"?>
+<p:sld xmlns:a="http://schemas.openxmlformats.org/drawingml/2006/main" xmlns:p="http://schemas.openxmlformats.org/presentationml/2006/main" xmlns:r="http://schemas.openxmlformats.org/officeDocument/2006/relationships">
+  <p:cSld>
+    <p:spTree>
+      <p:nvGrpSpPr>
+        <p:cNvPr id="1" name=""/>
+        <p:cNvGrpSpPr/>
+        <p:nvPr/>
+      </p:nvGrpSpPr>
+      <p:grpSpPr/>
+      <p:sp>
+        <p:nvSpPr>
+          <p:cNvPr id="2" name="Title 1"/>
+          <p:cNvSpPr>
+            <a:spLocks noGrp="1"/>
+          </p:cNvSpPr>
+          <p:nvPr>
+            <p:ph type="title"/>
+          </p:nvPr>
+        </p:nvSpPr>
+        <p:spPr/>
+        <p:txBody>
+          <a:bodyPr/>
+          <a:lstStyle/>
+          <a:p>
+            <a:r>
+              <a:t>Code Flow: Payment Gateway Integration</a:t>
+            </a:r>
+          </a:p>
+        </p:txBody>
+      </p:sp>
+      <p:sp>
+        <p:nvSpPr>
+          <p:cNvPr id="3" name="Text Placeholder 2"/>
+          <p:cNvSpPr>
+            <a:spLocks noGrp="1"/>
+          </p:cNvSpPr>
+          <p:nvPr>
+            <p:ph type="body" idx="1"/>
+          </p:nvPr>
+        </p:nvSpPr>
+        <p:spPr/>
+        <p:txBody>
+          <a:bodyPr/>
+          <a:lstStyle/>
+          <a:p>
+            <a:r>
+              <a:t>Implementation of Razorpay order creation for fee payments:</a:t>
+            </a:r>
+          </a:p>
+          <a:p>
+            <a:br/>
+            <a:pPr>
+              <a:defRPr sz="1200">
+                <a:latin typeface="Courier New"/>
+              </a:defRPr>
+            </a:pPr>
+            <a:r>
+              <a:t>def create_razorpay_order(payload, request):</a:t>
+            </a:r>
+            <a:br/>
+            <a:r>
+              <a:t>    user = _get_current_user(request)</a:t>
+            </a:r>
+            <a:br/>
+            <a:r>
+              <a:t>    if not (RAZORPAY_KEY_ID and RAZORPAY_KEY_SECRET):</a:t>
+            </a:r>
+            <a:br/>
+            <a:r>
+              <a:t>        raise HTTPException(status_code=503, detail="Razorpay not configured")</a:t>
+            </a:r>
+            <a:br/>
+            <a:br/>
+            <a:r>
+              <a:t>    student_id = payload.student_id or user["user"]</a:t>
+            </a:r>
+            <a:br/>
+            <a:r>
+              <a:t>    conn = get_connection()</a:t>
+            </a:r>
+            <a:br/>
+            <a:r>
+              <a:t>    info = _student_financials(conn, student_id)</a:t>
+            </a:r>
+            <a:br/>
+            <a:r>
+              <a:t>    conn.close()</a:t>
+            </a:r>
+            <a:br/>
+            <a:br/>
+            <a:r>
+              <a:t>    amount_paise = int(round(amount_inr * 100))</a:t>
+            </a:r>
+            <a:br/>
+            <a:r>
+              <a:t>    receipt = f"fee-{student_id}-{int(time.time())}"</a:t>
+            </a:r>
+            <a:br/>
+            <a:r>
+              <a:t>    </a:t>
+            </a:r>
+            <a:br/>
+            <a:r>
+              <a:t>    order = _create_razorpay_order(</a:t>
+            </a:r>
+            <a:br/>
+            <a:r>
+              <a:t>        amount_paise=amount_paise,</a:t>
+            </a:r>
+            <a:br/>
+            <a:r>
+              <a:t>        receipt=receipt,</a:t>
+            </a:r>
+            <a:br/>
+            <a:r>
+              <a:t>        notes={"student_id": student_id, "course": info["student"]["course"]}</a:t>
+            </a:r>
+            <a:br/>
+            <a:r>
+              <a:t>    )</a:t>
+            </a:r>
+            <a:br/>
+            <a:r>
+              <a:t>    return order</a:t>
+            </a:r>
+            <a:br/>
+          </a:p>
+        </p:txBody>
+      </p:sp>
+    </p:spTree>
+  </p:cSld>
+  <p:clrMapOvr>
+    <a:masterClrMapping/>
+  </p:clrMapOvr>
+</p:sld>
+</file>
+
+<file path=ppt/slides/slide18.xml><?xml version="1.0" encoding="utf-8"?>
+<p:sld xmlns:a="http://schemas.openxmlformats.org/drawingml/2006/main" xmlns:p="http://schemas.openxmlformats.org/presentationml/2006/main" xmlns:r="http://schemas.openxmlformats.org/officeDocument/2006/relationships">
+  <p:cSld>
+    <p:spTree>
+      <p:nvGrpSpPr>
+        <p:cNvPr id="1" name=""/>
+        <p:cNvGrpSpPr/>
+        <p:nvPr/>
+      </p:nvGrpSpPr>
+      <p:grpSpPr/>
+      <p:sp>
+        <p:nvSpPr>
+          <p:cNvPr id="2" name="Title 1"/>
+          <p:cNvSpPr>
+            <a:spLocks noGrp="1"/>
+          </p:cNvSpPr>
+          <p:nvPr>
+            <p:ph type="title"/>
+          </p:nvPr>
+        </p:nvSpPr>
+        <p:spPr/>
+        <p:txBody>
+          <a:bodyPr/>
+          <a:lstStyle/>
+          <a:p>
+            <a:r>
+              <a:t>System Output: Staff Dashboard</a:t>
+            </a:r>
+          </a:p>
+        </p:txBody>
+      </p:sp>
+      <p:sp>
+        <p:nvSpPr>
+          <p:cNvPr id="3" name="Subtitle 2"/>
+          <p:cNvSpPr>
+            <a:spLocks noGrp="1"/>
+          </p:cNvSpPr>
+          <p:nvPr>
+            <p:ph type="subTitle" idx="1"/>
+          </p:nvPr>
+        </p:nvSpPr>
+        <p:spPr/>
+        <p:txBody>
+          <a:bodyPr/>
+          <a:lstStyle/>
+          <a:p/>
+        </p:txBody>
+      </p:sp>
+      <p:sp>
+        <p:nvSpPr>
+          <p:cNvPr id="4" name="Text Placeholder 3"/>
+          <p:cNvSpPr>
+            <a:spLocks noGrp="1"/>
+          </p:cNvSpPr>
+          <p:nvPr>
+            <p:ph type="body" idx="2"/>
+          </p:nvPr>
+        </p:nvSpPr>
+        <p:spPr/>
+        <p:txBody>
+          <a:bodyPr/>
+          <a:lstStyle/>
+          <a:p/>
+        </p:txBody>
+      </p:sp>
+      <p:pic>
+        <p:nvPicPr>
+          <p:cNvPr id="5" name="Picture 4" descr="staff_dashboard.png"/>
+          <p:cNvPicPr>
+            <a:picLocks noChangeAspect="1"/>
+          </p:cNvPicPr>
+          <p:nvPr/>
+        </p:nvPicPr>
+        <p:blipFill>
+          <a:blip r:embed="rId2"/>
+          <a:stretch>
+            <a:fillRect/>
+          </a:stretch>
+        </p:blipFill>
+        <p:spPr>
+          <a:xfrm>
+            <a:off x="914400" y="1828800"/>
+            <a:ext cx="7315200" cy="4114800"/>
+          </a:xfrm>
+          <a:prstGeom prst="rect">
+            <a:avLst/>
+          </a:prstGeom>
+        </p:spPr>
+      </p:pic>
+    </p:spTree>
+  </p:cSld>
+  <p:clrMapOvr>
+    <a:masterClrMapping/>
+  </p:clrMapOvr>
+</p:sld>
+</file>
+
+<file path=ppt/slides/slide19.xml><?xml version="1.0" encoding="utf-8"?>
+<p:sld xmlns:a="http://schemas.openxmlformats.org/drawingml/2006/main" xmlns:p="http://schemas.openxmlformats.org/presentationml/2006/main" xmlns:r="http://schemas.openxmlformats.org/officeDocument/2006/relationships">
+  <p:cSld>
+    <p:spTree>
+      <p:nvGrpSpPr>
+        <p:cNvPr id="1" name=""/>
+        <p:cNvGrpSpPr/>
+        <p:nvPr/>
+      </p:nvGrpSpPr>
+      <p:grpSpPr/>
+      <p:sp>
+        <p:nvSpPr>
+          <p:cNvPr id="2" name="Title 1"/>
+          <p:cNvSpPr>
+            <a:spLocks noGrp="1"/>
+          </p:cNvSpPr>
+          <p:nvPr>
+            <p:ph type="title"/>
+          </p:nvPr>
+        </p:nvSpPr>
+        <p:spPr/>
+        <p:txBody>
+          <a:bodyPr/>
+          <a:lstStyle/>
+          <a:p>
+            <a:r>
+              <a:t>System Output: Student Dashboard</a:t>
+            </a:r>
+          </a:p>
+        </p:txBody>
+      </p:sp>
+      <p:sp>
+        <p:nvSpPr>
+          <p:cNvPr id="3" name="Subtitle 2"/>
+          <p:cNvSpPr>
+            <a:spLocks noGrp="1"/>
+          </p:cNvSpPr>
+          <p:nvPr>
+            <p:ph type="subTitle" idx="1"/>
+          </p:nvPr>
+        </p:nvSpPr>
+        <p:spPr/>
+        <p:txBody>
+          <a:bodyPr/>
+          <a:lstStyle/>
+          <a:p/>
+        </p:txBody>
+      </p:sp>
+      <p:sp>
+        <p:nvSpPr>
+          <p:cNvPr id="4" name="Text Placeholder 3"/>
+          <p:cNvSpPr>
+            <a:spLocks noGrp="1"/>
+          </p:cNvSpPr>
+          <p:nvPr>
+            <p:ph type="body" idx="2"/>
+          </p:nvPr>
+        </p:nvSpPr>
+        <p:spPr/>
+        <p:txBody>
+          <a:bodyPr/>
+          <a:lstStyle/>
+          <a:p/>
+        </p:txBody>
+      </p:sp>
+      <p:pic>
+        <p:nvPicPr>
+          <p:cNvPr id="5" name="Picture 4" descr="student_dashboard.png"/>
+          <p:cNvPicPr>
+            <a:picLocks noChangeAspect="1"/>
+          </p:cNvPicPr>
+          <p:nvPr/>
+        </p:nvPicPr>
+        <p:blipFill>
+          <a:blip r:embed="rId2"/>
+          <a:stretch>
+            <a:fillRect/>
+          </a:stretch>
+        </p:blipFill>
+        <p:spPr>
+          <a:xfrm>
+            <a:off x="914400" y="1828800"/>
+            <a:ext cx="7315200" cy="4114800"/>
+          </a:xfrm>
+          <a:prstGeom prst="rect">
+            <a:avLst/>
+          </a:prstGeom>
+        </p:spPr>
+      </p:pic>
+    </p:spTree>
+  </p:cSld>
+  <p:clrMapOvr>
+    <a:masterClrMapping/>
+  </p:clrMapOvr>
+</p:sld>
+</file>
+
 <file path=ppt/slides/slide2.xml><?xml version="1.0" encoding="utf-8"?>
 <p:sld xmlns:a="http://schemas.openxmlformats.org/drawingml/2006/main" xmlns:r="http://schemas.openxmlformats.org/officeDocument/2006/relationships" xmlns:p="http://schemas.openxmlformats.org/presentationml/2006/main">
   <p:cSld>
@@ -9440,6 +9775,87 @@
         <p14:creationId xmlns:p14="http://schemas.microsoft.com/office/powerpoint/2010/main" val="3991872289"/>
       </p:ext>
     </p:extLst>
+  </p:cSld>
+  <p:clrMapOvr>
+    <a:masterClrMapping/>
+  </p:clrMapOvr>
+</p:sld>
+</file>
+
+<file path=ppt/slides/slide20.xml><?xml version="1.0" encoding="utf-8"?>
+<p:sld xmlns:a="http://schemas.openxmlformats.org/drawingml/2006/main" xmlns:p="http://schemas.openxmlformats.org/presentationml/2006/main" xmlns:r="http://schemas.openxmlformats.org/officeDocument/2006/relationships">
+  <p:cSld>
+    <p:spTree>
+      <p:nvGrpSpPr>
+        <p:cNvPr id="1" name=""/>
+        <p:cNvGrpSpPr/>
+        <p:nvPr/>
+      </p:nvGrpSpPr>
+      <p:grpSpPr/>
+      <p:sp>
+        <p:nvSpPr>
+          <p:cNvPr id="2" name="Title 1"/>
+          <p:cNvSpPr>
+            <a:spLocks noGrp="1"/>
+          </p:cNvSpPr>
+          <p:nvPr>
+            <p:ph type="title"/>
+          </p:nvPr>
+        </p:nvSpPr>
+        <p:spPr/>
+        <p:txBody>
+          <a:bodyPr/>
+          <a:lstStyle/>
+          <a:p/>
+        </p:txBody>
+      </p:sp>
+      <p:sp>
+        <p:nvSpPr>
+          <p:cNvPr id="3" name="Text Placeholder 2"/>
+          <p:cNvSpPr>
+            <a:spLocks noGrp="1"/>
+          </p:cNvSpPr>
+          <p:nvPr>
+            <p:ph type="body" idx="1"/>
+          </p:nvPr>
+        </p:nvSpPr>
+        <p:spPr/>
+        <p:txBody>
+          <a:bodyPr/>
+          <a:lstStyle/>
+          <a:p/>
+        </p:txBody>
+      </p:sp>
+      <p:sp>
+        <p:nvSpPr>
+          <p:cNvPr id="4" name="TextBox 3"/>
+          <p:cNvSpPr txBox="1"/>
+          <p:nvPr/>
+        </p:nvSpPr>
+        <p:spPr>
+          <a:xfrm>
+            <a:off x="3810000" y="2971800"/>
+            <a:ext cx="1898100" cy="763500"/>
+          </a:xfrm>
+          <a:prstGeom prst="rect">
+            <a:avLst/>
+          </a:prstGeom>
+          <a:noFill/>
+        </p:spPr>
+        <p:txBody>
+          <a:bodyPr wrap="none">
+            <a:spAutoFit/>
+          </a:bodyPr>
+          <a:lstStyle/>
+          <a:p>
+            <a:r>
+              <a:rPr/>
+              <a:t>Thank you</a:t>
+            </a:r>
+          </a:p>
+        </p:txBody>
+      </p:sp>
+    </p:spTree>
   </p:cSld>
   <p:clrMapOvr>
     <a:masterClrMapping/>

</xml_diff>